<commit_message>
feat: complete ecommerce sales performance analysis deliverables
- Dashboard: Power BI file and exported visualization
- Data: raw and cleaned CSV datasets
- Analysis: Jupyter notebooks
- Documentation: presentation and final report
</commit_message>
<xml_diff>
--- a/ecommerce_analysis.pptx
+++ b/ecommerce_analysis.pptx
@@ -5,20 +5,21 @@
     <p:sldMasterId id="2147483648" r:id="rId1"/>
   </p:sldMasterIdLst>
   <p:notesMasterIdLst>
-    <p:notesMasterId r:id="rId13"/>
+    <p:notesMasterId r:id="rId14"/>
   </p:notesMasterIdLst>
   <p:sldIdLst>
     <p:sldId id="256" r:id="rId2"/>
     <p:sldId id="257" r:id="rId3"/>
     <p:sldId id="258" r:id="rId4"/>
     <p:sldId id="259" r:id="rId5"/>
-    <p:sldId id="260" r:id="rId6"/>
-    <p:sldId id="261" r:id="rId7"/>
-    <p:sldId id="262" r:id="rId8"/>
-    <p:sldId id="263" r:id="rId9"/>
-    <p:sldId id="264" r:id="rId10"/>
-    <p:sldId id="265" r:id="rId11"/>
-    <p:sldId id="266" r:id="rId12"/>
+    <p:sldId id="267" r:id="rId6"/>
+    <p:sldId id="260" r:id="rId7"/>
+    <p:sldId id="261" r:id="rId8"/>
+    <p:sldId id="262" r:id="rId9"/>
+    <p:sldId id="263" r:id="rId10"/>
+    <p:sldId id="264" r:id="rId11"/>
+    <p:sldId id="265" r:id="rId12"/>
+    <p:sldId id="266" r:id="rId13"/>
   </p:sldIdLst>
   <p:sldSz cx="9144000" cy="5143500" type="screen16x9"/>
   <p:notesSz cx="5143500" cy="9144000"/>
@@ -499,6 +500,90 @@
 </p:notes>
 </file>
 
+<file path=ppt/notesSlides/notesSlide12.xml><?xml version="1.0" encoding="utf-8"?>
+<p:notes xmlns:a="http://schemas.openxmlformats.org/drawingml/2006/main" xmlns:r="http://schemas.openxmlformats.org/officeDocument/2006/relationships" xmlns:p="http://schemas.openxmlformats.org/presentationml/2006/main">
+  <p:cSld>
+    <p:spTree>
+      <p:nvGrpSpPr>
+        <p:cNvPr id="1" name=""/>
+        <p:cNvGrpSpPr/>
+        <p:nvPr/>
+      </p:nvGrpSpPr>
+      <p:grpSpPr>
+        <a:xfrm>
+          <a:off x="0" y="0"/>
+          <a:ext cx="0" cy="0"/>
+          <a:chOff x="0" y="0"/>
+          <a:chExt cx="0" cy="0"/>
+        </a:xfrm>
+      </p:grpSpPr>
+      <p:sp>
+        <p:nvSpPr>
+          <p:cNvPr id="2" name="Slide Image Placeholder 1"/>
+          <p:cNvSpPr>
+            <a:spLocks noGrp="1" noRot="1" noChangeAspect="1"/>
+          </p:cNvSpPr>
+          <p:nvPr>
+            <p:ph type="sldImg"/>
+          </p:nvPr>
+        </p:nvSpPr>
+        <p:spPr/>
+      </p:sp>
+      <p:sp>
+        <p:nvSpPr>
+          <p:cNvPr id="3" name="Notes Placeholder 2"/>
+          <p:cNvSpPr>
+            <a:spLocks noGrp="1"/>
+          </p:cNvSpPr>
+          <p:nvPr>
+            <p:ph type="body" idx="1"/>
+          </p:nvPr>
+        </p:nvSpPr>
+        <p:spPr/>
+        <p:txBody>
+          <a:bodyPr/>
+          <a:lstStyle/>
+          <a:p>
+            <a:endParaRPr lang="en-US" dirty="0"/>
+          </a:p>
+        </p:txBody>
+      </p:sp>
+      <p:sp>
+        <p:nvSpPr>
+          <p:cNvPr id="4" name="Slide Number Placeholder 3"/>
+          <p:cNvSpPr>
+            <a:spLocks noGrp="1"/>
+          </p:cNvSpPr>
+          <p:nvPr>
+            <p:ph type="sldNum" sz="quarter" idx="10"/>
+          </p:nvPr>
+        </p:nvSpPr>
+        <p:spPr/>
+        <p:txBody>
+          <a:bodyPr/>
+          <a:lstStyle/>
+          <a:p>
+            <a:fld id="{F7021451-1387-4CA6-816F-3879F97B5CBC}" type="slidenum">
+              <a:rPr lang="en-US"/>
+              <a:t>12</a:t>
+            </a:fld>
+            <a:endParaRPr lang="en-US"/>
+          </a:p>
+        </p:txBody>
+      </p:sp>
+    </p:spTree>
+    <p:extLst>
+      <p:ext uri="{BB962C8B-B14F-4D97-AF65-F5344CB8AC3E}">
+        <p14:creationId xmlns:p14="http://schemas.microsoft.com/office/powerpoint/2010/main" val="1024086991"/>
+      </p:ext>
+    </p:extLst>
+  </p:cSld>
+  <p:clrMapOvr>
+    <a:masterClrMapping/>
+  </p:clrMapOvr>
+</p:notes>
+</file>
+
 <file path=ppt/notesSlides/notesSlide2.xml><?xml version="1.0" encoding="utf-8"?>
 <p:notes xmlns:a="http://schemas.openxmlformats.org/drawingml/2006/main" xmlns:r="http://schemas.openxmlformats.org/officeDocument/2006/relationships" xmlns:p="http://schemas.openxmlformats.org/presentationml/2006/main">
   <p:cSld>
@@ -825,7 +910,7 @@
     </p:spTree>
     <p:extLst>
       <p:ext uri="{BB962C8B-B14F-4D97-AF65-F5344CB8AC3E}">
-        <p14:creationId xmlns:p14="http://schemas.microsoft.com/office/powerpoint/2010/main" val="1024086991"/>
+        <p14:creationId xmlns:p14="http://schemas.microsoft.com/office/powerpoint/2010/main" val="869237970"/>
       </p:ext>
     </p:extLst>
   </p:cSld>
@@ -1725,18 +1810,7 @@
                 <a:ea typeface="Calibri" pitchFamily="34" charset="-122"/>
                 <a:cs typeface="Calibri" pitchFamily="34" charset="-120"/>
               </a:rPr>
-              <a:t>Presented by: Happy </a:t>
-            </a:r>
-            <a:r>
-              <a:rPr lang="en-US" sz="1100" i="1" dirty="0" err="1">
-                <a:solidFill>
-                  <a:srgbClr val="94A3B8"/>
-                </a:solidFill>
-                <a:latin typeface="Calibri" pitchFamily="34" charset="0"/>
-                <a:ea typeface="Calibri" pitchFamily="34" charset="-122"/>
-                <a:cs typeface="Calibri" pitchFamily="34" charset="-120"/>
-              </a:rPr>
-              <a:t>Anywuli</a:t>
+              <a:t>Presented by: Gogo Harrison</a:t>
             </a:r>
             <a:endParaRPr lang="en-US" sz="1100" dirty="0"/>
           </a:p>
@@ -1751,6 +1825,350 @@
 </file>
 
 <file path=ppt/slides/slide10.xml><?xml version="1.0" encoding="utf-8"?>
+<p:sld xmlns:a="http://schemas.openxmlformats.org/drawingml/2006/main" xmlns:r="http://schemas.openxmlformats.org/officeDocument/2006/relationships" xmlns:p="http://schemas.openxmlformats.org/presentationml/2006/main">
+  <p:cSld name="Slide 9">
+    <p:bg>
+      <p:bgPr>
+        <a:solidFill>
+          <a:srgbClr val="F8FAFC"/>
+        </a:solidFill>
+        <a:effectLst/>
+      </p:bgPr>
+    </p:bg>
+    <p:spTree>
+      <p:nvGrpSpPr>
+        <p:cNvPr id="1" name=""/>
+        <p:cNvGrpSpPr/>
+        <p:nvPr/>
+      </p:nvGrpSpPr>
+      <p:grpSpPr>
+        <a:xfrm>
+          <a:off x="0" y="0"/>
+          <a:ext cx="0" cy="0"/>
+          <a:chOff x="0" y="0"/>
+          <a:chExt cx="0" cy="0"/>
+        </a:xfrm>
+      </p:grpSpPr>
+      <p:sp>
+        <p:nvSpPr>
+          <p:cNvPr id="2" name="Shape 0"/>
+          <p:cNvSpPr/>
+          <p:nvPr/>
+        </p:nvSpPr>
+        <p:spPr>
+          <a:xfrm>
+            <a:off x="0" y="0"/>
+            <a:ext cx="9144000" cy="685800"/>
+          </a:xfrm>
+          <a:prstGeom prst="rect">
+            <a:avLst/>
+          </a:prstGeom>
+          <a:solidFill>
+            <a:srgbClr val="1B3A6B"/>
+          </a:solidFill>
+          <a:ln/>
+        </p:spPr>
+      </p:sp>
+      <p:sp>
+        <p:nvSpPr>
+          <p:cNvPr id="3" name="Text 1"/>
+          <p:cNvSpPr/>
+          <p:nvPr/>
+        </p:nvSpPr>
+        <p:spPr>
+          <a:xfrm>
+            <a:off x="365760" y="64008"/>
+            <a:ext cx="8412480" cy="548640"/>
+          </a:xfrm>
+          <a:prstGeom prst="rect">
+            <a:avLst/>
+          </a:prstGeom>
+          <a:noFill/>
+          <a:ln/>
+        </p:spPr>
+        <p:txBody>
+          <a:bodyPr wrap="square" rtlCol="0" anchor="ctr"/>
+          <a:lstStyle/>
+          <a:p>
+            <a:pPr marL="0" indent="0">
+              <a:buNone/>
+            </a:pPr>
+            <a:r>
+              <a:rPr lang="en-US" sz="2000" b="1" dirty="0">
+                <a:solidFill>
+                  <a:srgbClr val="FFFFFF"/>
+                </a:solidFill>
+              </a:rPr>
+              <a:t>Product Performance Insights</a:t>
+            </a:r>
+            <a:endParaRPr lang="en-US" sz="2000" dirty="0"/>
+          </a:p>
+        </p:txBody>
+      </p:sp>
+      <p:pic>
+        <p:nvPicPr>
+          <p:cNvPr id="4" name="Image 0" descr="preencoded.png"/>
+          <p:cNvPicPr>
+            <a:picLocks noChangeAspect="1"/>
+          </p:cNvPicPr>
+          <p:nvPr/>
+        </p:nvPicPr>
+        <p:blipFill>
+          <a:blip r:embed="rId3"/>
+          <a:stretch>
+            <a:fillRect/>
+          </a:stretch>
+        </p:blipFill>
+        <p:spPr>
+          <a:xfrm>
+            <a:off x="274320" y="777240"/>
+            <a:ext cx="4846320" cy="2331720"/>
+          </a:xfrm>
+          <a:prstGeom prst="rect">
+            <a:avLst/>
+          </a:prstGeom>
+        </p:spPr>
+      </p:pic>
+      <p:pic>
+        <p:nvPicPr>
+          <p:cNvPr id="5" name="Image 1" descr="preencoded.png"/>
+          <p:cNvPicPr>
+            <a:picLocks noChangeAspect="1"/>
+          </p:cNvPicPr>
+          <p:nvPr/>
+        </p:nvPicPr>
+        <p:blipFill>
+          <a:blip r:embed="rId4"/>
+          <a:stretch>
+            <a:fillRect/>
+          </a:stretch>
+        </p:blipFill>
+        <p:spPr>
+          <a:xfrm>
+            <a:off x="274320" y="3200400"/>
+            <a:ext cx="4846320" cy="1828800"/>
+          </a:xfrm>
+          <a:prstGeom prst="rect">
+            <a:avLst/>
+          </a:prstGeom>
+        </p:spPr>
+      </p:pic>
+      <p:sp>
+        <p:nvSpPr>
+          <p:cNvPr id="6" name="Shape 2"/>
+          <p:cNvSpPr/>
+          <p:nvPr/>
+        </p:nvSpPr>
+        <p:spPr>
+          <a:xfrm>
+            <a:off x="5303520" y="777240"/>
+            <a:ext cx="3566160" cy="4251960"/>
+          </a:xfrm>
+          <a:prstGeom prst="rect">
+            <a:avLst/>
+          </a:prstGeom>
+          <a:solidFill>
+            <a:srgbClr val="FFFFFF"/>
+          </a:solidFill>
+          <a:ln/>
+          <a:effectLst>
+            <a:outerShdw blurRad="101600" dist="38100" dir="16200000" algn="bl" rotWithShape="0">
+              <a:srgbClr val="000000">
+                <a:alpha val="10000"/>
+              </a:srgbClr>
+            </a:outerShdw>
+          </a:effectLst>
+        </p:spPr>
+      </p:sp>
+      <p:sp>
+        <p:nvSpPr>
+          <p:cNvPr id="7" name="Shape 3"/>
+          <p:cNvSpPr/>
+          <p:nvPr/>
+        </p:nvSpPr>
+        <p:spPr>
+          <a:xfrm>
+            <a:off x="5303520" y="777240"/>
+            <a:ext cx="64008" cy="4251960"/>
+          </a:xfrm>
+          <a:prstGeom prst="rect">
+            <a:avLst/>
+          </a:prstGeom>
+          <a:solidFill>
+            <a:srgbClr val="D97706"/>
+          </a:solidFill>
+          <a:ln/>
+        </p:spPr>
+      </p:sp>
+      <p:sp>
+        <p:nvSpPr>
+          <p:cNvPr id="8" name="Text 4"/>
+          <p:cNvSpPr/>
+          <p:nvPr/>
+        </p:nvSpPr>
+        <p:spPr>
+          <a:xfrm>
+            <a:off x="5486400" y="868680"/>
+            <a:ext cx="3200400" cy="365760"/>
+          </a:xfrm>
+          <a:prstGeom prst="rect">
+            <a:avLst/>
+          </a:prstGeom>
+          <a:noFill/>
+          <a:ln/>
+        </p:spPr>
+        <p:txBody>
+          <a:bodyPr wrap="square" rtlCol="0" anchor="ctr"/>
+          <a:lstStyle/>
+          <a:p>
+            <a:pPr marL="0" indent="0">
+              <a:buNone/>
+            </a:pPr>
+            <a:r>
+              <a:rPr lang="en-US" sz="1300" b="1" dirty="0">
+                <a:solidFill>
+                  <a:srgbClr val="1B3A6B"/>
+                </a:solidFill>
+              </a:rPr>
+              <a:t>Key Insights</a:t>
+            </a:r>
+            <a:endParaRPr lang="en-US" sz="1300" dirty="0"/>
+          </a:p>
+        </p:txBody>
+      </p:sp>
+      <p:sp>
+        <p:nvSpPr>
+          <p:cNvPr id="9" name="Text 5"/>
+          <p:cNvSpPr/>
+          <p:nvPr/>
+        </p:nvSpPr>
+        <p:spPr>
+          <a:xfrm>
+            <a:off x="5486400" y="1325880"/>
+            <a:ext cx="3200400" cy="3566160"/>
+          </a:xfrm>
+          <a:prstGeom prst="rect">
+            <a:avLst/>
+          </a:prstGeom>
+          <a:noFill/>
+          <a:ln/>
+        </p:spPr>
+        <p:txBody>
+          <a:bodyPr wrap="square" rtlCol="0" anchor="ctr"/>
+          <a:lstStyle/>
+          <a:p>
+            <a:pPr marL="0" indent="0">
+              <a:lnSpc>
+                <a:spcPct val="150000"/>
+              </a:lnSpc>
+              <a:buNone/>
+            </a:pPr>
+            <a:r>
+              <a:rPr lang="en-US" sz="1050" dirty="0">
+                <a:solidFill>
+                  <a:srgbClr val="0F172A"/>
+                </a:solidFill>
+              </a:rPr>
+              <a:t>🏆 Top 10 products generate disproportionate revenue</a:t>
+            </a:r>
+            <a:endParaRPr lang="en-US" sz="1050" dirty="0"/>
+          </a:p>
+          <a:p>
+            <a:pPr marL="0" indent="0">
+              <a:lnSpc>
+                <a:spcPct val="150000"/>
+              </a:lnSpc>
+              <a:buNone/>
+            </a:pPr>
+            <a:r>
+              <a:rPr lang="en-US" sz="1050" dirty="0">
+                <a:solidFill>
+                  <a:srgbClr val="0F172A"/>
+                </a:solidFill>
+              </a:rPr>
+              <a:t>🕯️ Decorative / gift items dominate top sellers</a:t>
+            </a:r>
+            <a:endParaRPr lang="en-US" sz="1050" dirty="0"/>
+          </a:p>
+          <a:p>
+            <a:pPr marL="0" indent="0">
+              <a:lnSpc>
+                <a:spcPct val="150000"/>
+              </a:lnSpc>
+              <a:buNone/>
+            </a:pPr>
+            <a:r>
+              <a:rPr lang="en-US" sz="1050" dirty="0">
+                <a:solidFill>
+                  <a:srgbClr val="0F172A"/>
+                </a:solidFill>
+              </a:rPr>
+              <a:t>⚠️  Many SKUs have &lt;£2 avg revenue per transaction</a:t>
+            </a:r>
+            <a:endParaRPr lang="en-US" sz="1050" dirty="0"/>
+          </a:p>
+          <a:p>
+            <a:pPr marL="0" indent="0">
+              <a:lnSpc>
+                <a:spcPct val="150000"/>
+              </a:lnSpc>
+              <a:buNone/>
+            </a:pPr>
+            <a:r>
+              <a:rPr lang="en-US" sz="1050" dirty="0">
+                <a:solidFill>
+                  <a:srgbClr val="0F172A"/>
+                </a:solidFill>
+              </a:rPr>
+              <a:t>📦 Bundling low-value items can boost basket size</a:t>
+            </a:r>
+            <a:endParaRPr lang="en-US" sz="1050" dirty="0"/>
+          </a:p>
+          <a:p>
+            <a:pPr marL="0" indent="0">
+              <a:lnSpc>
+                <a:spcPct val="150000"/>
+              </a:lnSpc>
+              <a:buNone/>
+            </a:pPr>
+            <a:r>
+              <a:rPr lang="en-US" sz="1050" dirty="0">
+                <a:solidFill>
+                  <a:srgbClr val="0F172A"/>
+                </a:solidFill>
+              </a:rPr>
+              <a:t>💡 Apply 80/20 rule: focus marketing budget on top 20% of SKUs</a:t>
+            </a:r>
+            <a:endParaRPr lang="en-US" sz="1050" dirty="0"/>
+          </a:p>
+          <a:p>
+            <a:pPr marL="0" indent="0">
+              <a:lnSpc>
+                <a:spcPct val="150000"/>
+              </a:lnSpc>
+              <a:buNone/>
+            </a:pPr>
+            <a:r>
+              <a:rPr lang="en-US" sz="1050" dirty="0">
+                <a:solidFill>
+                  <a:srgbClr val="0F172A"/>
+                </a:solidFill>
+              </a:rPr>
+              <a:t>🗑️ Consider discontinuing or repricing the bottom 50 SKUs</a:t>
+            </a:r>
+            <a:endParaRPr lang="en-US" sz="1050" dirty="0"/>
+          </a:p>
+        </p:txBody>
+      </p:sp>
+    </p:spTree>
+  </p:cSld>
+  <p:clrMapOvr>
+    <a:masterClrMapping/>
+  </p:clrMapOvr>
+</p:sld>
+</file>
+
+<file path=ppt/slides/slide11.xml><?xml version="1.0" encoding="utf-8"?>
 <p:sld xmlns:a="http://schemas.openxmlformats.org/drawingml/2006/main" xmlns:r="http://schemas.openxmlformats.org/officeDocument/2006/relationships" xmlns:p="http://schemas.openxmlformats.org/presentationml/2006/main">
   <p:cSld name="Slide 10">
     <p:bg>
@@ -2607,7 +3025,7 @@
 </p:sld>
 </file>
 
-<file path=ppt/slides/slide11.xml><?xml version="1.0" encoding="utf-8"?>
+<file path=ppt/slides/slide12.xml><?xml version="1.0" encoding="utf-8"?>
 <p:sld xmlns:a="http://schemas.openxmlformats.org/drawingml/2006/main" xmlns:r="http://schemas.openxmlformats.org/officeDocument/2006/relationships" xmlns:p="http://schemas.openxmlformats.org/presentationml/2006/main">
   <p:cSld name="Slide 11">
     <p:bg>
@@ -4911,6 +5329,462 @@
 
 <file path=ppt/slides/slide5.xml><?xml version="1.0" encoding="utf-8"?>
 <p:sld xmlns:a="http://schemas.openxmlformats.org/drawingml/2006/main" xmlns:r="http://schemas.openxmlformats.org/officeDocument/2006/relationships" xmlns:p="http://schemas.openxmlformats.org/presentationml/2006/main">
+  <p:cSld>
+    <p:bg>
+      <p:bgPr>
+        <a:solidFill>
+          <a:srgbClr val="F8FAFC"/>
+        </a:solidFill>
+        <a:effectLst/>
+      </p:bgPr>
+    </p:bg>
+    <p:spTree>
+      <p:nvGrpSpPr>
+        <p:cNvPr id="1" name=""/>
+        <p:cNvGrpSpPr/>
+        <p:nvPr/>
+      </p:nvGrpSpPr>
+      <p:grpSpPr>
+        <a:xfrm>
+          <a:off x="0" y="0"/>
+          <a:ext cx="0" cy="0"/>
+          <a:chOff x="0" y="0"/>
+          <a:chExt cx="0" cy="0"/>
+        </a:xfrm>
+      </p:grpSpPr>
+      <p:sp>
+        <p:nvSpPr>
+          <p:cNvPr id="3" name="Text 1"/>
+          <p:cNvSpPr/>
+          <p:nvPr/>
+        </p:nvSpPr>
+        <p:spPr>
+          <a:xfrm>
+            <a:off x="365760" y="64008"/>
+            <a:ext cx="8412480" cy="548640"/>
+          </a:xfrm>
+          <a:prstGeom prst="rect">
+            <a:avLst/>
+          </a:prstGeom>
+          <a:noFill/>
+          <a:ln/>
+        </p:spPr>
+        <p:txBody>
+          <a:bodyPr wrap="square" rtlCol="0" anchor="ctr"/>
+          <a:lstStyle/>
+          <a:p>
+            <a:pPr marL="0" indent="0">
+              <a:buNone/>
+            </a:pPr>
+            <a:r>
+              <a:rPr lang="en-US" sz="2000" b="1" dirty="0">
+                <a:solidFill>
+                  <a:srgbClr val="FFFFFF"/>
+                </a:solidFill>
+              </a:rPr>
+              <a:t>RFM Customer Segmentation</a:t>
+            </a:r>
+            <a:endParaRPr lang="en-US" sz="2000" dirty="0"/>
+          </a:p>
+        </p:txBody>
+      </p:sp>
+      <p:sp>
+        <p:nvSpPr>
+          <p:cNvPr id="6" name="Text 3"/>
+          <p:cNvSpPr/>
+          <p:nvPr/>
+        </p:nvSpPr>
+        <p:spPr>
+          <a:xfrm>
+            <a:off x="274320" y="3776472"/>
+            <a:ext cx="2011680" cy="274320"/>
+          </a:xfrm>
+          <a:prstGeom prst="rect">
+            <a:avLst/>
+          </a:prstGeom>
+          <a:noFill/>
+          <a:ln/>
+        </p:spPr>
+        <p:txBody>
+          <a:bodyPr wrap="square" rtlCol="0" anchor="ctr"/>
+          <a:lstStyle/>
+          <a:p>
+            <a:pPr marL="0" indent="0" algn="ctr">
+              <a:buNone/>
+            </a:pPr>
+            <a:r>
+              <a:rPr lang="en-US" sz="1100" b="1" dirty="0">
+                <a:solidFill>
+                  <a:srgbClr val="FFFFFF"/>
+                </a:solidFill>
+              </a:rPr>
+              <a:t>Champions</a:t>
+            </a:r>
+            <a:endParaRPr lang="en-US" sz="1100" dirty="0"/>
+          </a:p>
+        </p:txBody>
+      </p:sp>
+      <p:sp>
+        <p:nvSpPr>
+          <p:cNvPr id="7" name="Text 4"/>
+          <p:cNvSpPr/>
+          <p:nvPr/>
+        </p:nvSpPr>
+        <p:spPr>
+          <a:xfrm>
+            <a:off x="274320" y="4050792"/>
+            <a:ext cx="2011680" cy="365760"/>
+          </a:xfrm>
+          <a:prstGeom prst="rect">
+            <a:avLst/>
+          </a:prstGeom>
+          <a:noFill/>
+          <a:ln/>
+        </p:spPr>
+        <p:txBody>
+          <a:bodyPr wrap="square" rtlCol="0" anchor="ctr"/>
+          <a:lstStyle/>
+          <a:p>
+            <a:pPr marL="0" indent="0" algn="ctr">
+              <a:lnSpc>
+                <a:spcPct val="130000"/>
+              </a:lnSpc>
+              <a:buNone/>
+            </a:pPr>
+            <a:r>
+              <a:rPr lang="en-US" sz="950" dirty="0">
+                <a:solidFill>
+                  <a:srgbClr val="FFFFFF"/>
+                </a:solidFill>
+              </a:rPr>
+              <a:t>934 customers</a:t>
+            </a:r>
+            <a:endParaRPr lang="en-US" sz="950" dirty="0"/>
+          </a:p>
+          <a:p>
+            <a:pPr marL="0" indent="0" algn="ctr">
+              <a:lnSpc>
+                <a:spcPct val="130000"/>
+              </a:lnSpc>
+              <a:buNone/>
+            </a:pPr>
+            <a:r>
+              <a:rPr lang="en-US" sz="950" dirty="0">
+                <a:solidFill>
+                  <a:srgbClr val="FFFFFF"/>
+                </a:solidFill>
+              </a:rPr>
+              <a:t>£6.3M</a:t>
+            </a:r>
+            <a:endParaRPr lang="en-US" sz="950" dirty="0"/>
+          </a:p>
+        </p:txBody>
+      </p:sp>
+      <p:sp>
+        <p:nvSpPr>
+          <p:cNvPr id="8" name="Text 5"/>
+          <p:cNvSpPr/>
+          <p:nvPr/>
+        </p:nvSpPr>
+        <p:spPr>
+          <a:xfrm>
+            <a:off x="63795" y="4621618"/>
+            <a:ext cx="9002233" cy="457873"/>
+          </a:xfrm>
+          <a:prstGeom prst="rect">
+            <a:avLst/>
+          </a:prstGeom>
+          <a:noFill/>
+          <a:ln/>
+        </p:spPr>
+        <p:txBody>
+          <a:bodyPr wrap="square" rtlCol="0" anchor="ctr"/>
+          <a:lstStyle/>
+          <a:p>
+            <a:pPr marL="0" indent="0" algn="just">
+              <a:buNone/>
+            </a:pPr>
+            <a:r>
+              <a:rPr lang="en-US" sz="1400" i="1" dirty="0"/>
+              <a:t>Full dashboard available as an interactive Power BI file with dynamic filtering by Year, Country, Customer Segment, and Quarter. Download the .</a:t>
+            </a:r>
+            <a:r>
+              <a:rPr lang="en-US" sz="1400" i="1" dirty="0" err="1"/>
+              <a:t>pbix</a:t>
+            </a:r>
+            <a:r>
+              <a:rPr lang="en-US" sz="1400" i="1" dirty="0"/>
+              <a:t> file from the project repository to explore.</a:t>
+            </a:r>
+            <a:endParaRPr lang="en-US" sz="1400" dirty="0"/>
+          </a:p>
+        </p:txBody>
+      </p:sp>
+      <p:sp>
+        <p:nvSpPr>
+          <p:cNvPr id="10" name="Text 7"/>
+          <p:cNvSpPr/>
+          <p:nvPr/>
+        </p:nvSpPr>
+        <p:spPr>
+          <a:xfrm>
+            <a:off x="2450592" y="3776472"/>
+            <a:ext cx="2011680" cy="274320"/>
+          </a:xfrm>
+          <a:prstGeom prst="rect">
+            <a:avLst/>
+          </a:prstGeom>
+          <a:noFill/>
+          <a:ln/>
+        </p:spPr>
+        <p:txBody>
+          <a:bodyPr wrap="square" rtlCol="0" anchor="ctr"/>
+          <a:lstStyle/>
+          <a:p>
+            <a:pPr marL="0" indent="0" algn="ctr">
+              <a:buNone/>
+            </a:pPr>
+            <a:r>
+              <a:rPr lang="en-US" sz="1100" b="1" dirty="0">
+                <a:solidFill>
+                  <a:srgbClr val="FFFFFF"/>
+                </a:solidFill>
+              </a:rPr>
+              <a:t>Loyal</a:t>
+            </a:r>
+            <a:endParaRPr lang="en-US" sz="1100" dirty="0"/>
+          </a:p>
+        </p:txBody>
+      </p:sp>
+      <p:sp>
+        <p:nvSpPr>
+          <p:cNvPr id="14" name="Text 11"/>
+          <p:cNvSpPr/>
+          <p:nvPr/>
+        </p:nvSpPr>
+        <p:spPr>
+          <a:xfrm>
+            <a:off x="4626864" y="3776472"/>
+            <a:ext cx="2011680" cy="274320"/>
+          </a:xfrm>
+          <a:prstGeom prst="rect">
+            <a:avLst/>
+          </a:prstGeom>
+          <a:noFill/>
+          <a:ln/>
+        </p:spPr>
+        <p:txBody>
+          <a:bodyPr wrap="square" rtlCol="0" anchor="ctr"/>
+          <a:lstStyle/>
+          <a:p>
+            <a:pPr marL="0" indent="0" algn="ctr">
+              <a:buNone/>
+            </a:pPr>
+            <a:r>
+              <a:rPr lang="en-US" sz="1100" b="1" dirty="0">
+                <a:solidFill>
+                  <a:srgbClr val="FFFFFF"/>
+                </a:solidFill>
+              </a:rPr>
+              <a:t>At Risk</a:t>
+            </a:r>
+            <a:endParaRPr lang="en-US" sz="1100" dirty="0"/>
+          </a:p>
+        </p:txBody>
+      </p:sp>
+      <p:sp>
+        <p:nvSpPr>
+          <p:cNvPr id="15" name="Text 12"/>
+          <p:cNvSpPr/>
+          <p:nvPr/>
+        </p:nvSpPr>
+        <p:spPr>
+          <a:xfrm>
+            <a:off x="4626864" y="4050792"/>
+            <a:ext cx="2011680" cy="365760"/>
+          </a:xfrm>
+          <a:prstGeom prst="rect">
+            <a:avLst/>
+          </a:prstGeom>
+          <a:noFill/>
+          <a:ln/>
+        </p:spPr>
+        <p:txBody>
+          <a:bodyPr wrap="square" rtlCol="0" anchor="ctr"/>
+          <a:lstStyle/>
+          <a:p>
+            <a:pPr marL="0" indent="0" algn="ctr">
+              <a:lnSpc>
+                <a:spcPct val="130000"/>
+              </a:lnSpc>
+              <a:buNone/>
+            </a:pPr>
+            <a:r>
+              <a:rPr lang="en-US" sz="950" dirty="0">
+                <a:solidFill>
+                  <a:srgbClr val="FFFFFF"/>
+                </a:solidFill>
+              </a:rPr>
+              <a:t>800 customers</a:t>
+            </a:r>
+            <a:endParaRPr lang="en-US" sz="950" dirty="0"/>
+          </a:p>
+          <a:p>
+            <a:pPr marL="0" indent="0" algn="ctr">
+              <a:lnSpc>
+                <a:spcPct val="130000"/>
+              </a:lnSpc>
+              <a:buNone/>
+            </a:pPr>
+            <a:r>
+              <a:rPr lang="en-US" sz="950" dirty="0">
+                <a:solidFill>
+                  <a:srgbClr val="FFFFFF"/>
+                </a:solidFill>
+              </a:rPr>
+              <a:t>£430K</a:t>
+            </a:r>
+            <a:endParaRPr lang="en-US" sz="950" dirty="0"/>
+          </a:p>
+        </p:txBody>
+      </p:sp>
+      <p:sp>
+        <p:nvSpPr>
+          <p:cNvPr id="18" name="Text 15"/>
+          <p:cNvSpPr/>
+          <p:nvPr/>
+        </p:nvSpPr>
+        <p:spPr>
+          <a:xfrm>
+            <a:off x="6803136" y="3776472"/>
+            <a:ext cx="2011680" cy="274320"/>
+          </a:xfrm>
+          <a:prstGeom prst="rect">
+            <a:avLst/>
+          </a:prstGeom>
+          <a:noFill/>
+          <a:ln/>
+        </p:spPr>
+        <p:txBody>
+          <a:bodyPr wrap="square" rtlCol="0" anchor="ctr"/>
+          <a:lstStyle/>
+          <a:p>
+            <a:pPr marL="0" indent="0" algn="ctr">
+              <a:buNone/>
+            </a:pPr>
+            <a:r>
+              <a:rPr lang="en-US" sz="1100" b="1" dirty="0">
+                <a:solidFill>
+                  <a:srgbClr val="FFFFFF"/>
+                </a:solidFill>
+              </a:rPr>
+              <a:t>Lost</a:t>
+            </a:r>
+            <a:endParaRPr lang="en-US" sz="1100" dirty="0"/>
+          </a:p>
+        </p:txBody>
+      </p:sp>
+      <p:sp>
+        <p:nvSpPr>
+          <p:cNvPr id="19" name="Text 16"/>
+          <p:cNvSpPr/>
+          <p:nvPr/>
+        </p:nvSpPr>
+        <p:spPr>
+          <a:xfrm>
+            <a:off x="6803136" y="4050792"/>
+            <a:ext cx="2011680" cy="365760"/>
+          </a:xfrm>
+          <a:prstGeom prst="rect">
+            <a:avLst/>
+          </a:prstGeom>
+          <a:noFill/>
+          <a:ln/>
+        </p:spPr>
+        <p:txBody>
+          <a:bodyPr wrap="square" rtlCol="0" anchor="ctr"/>
+          <a:lstStyle/>
+          <a:p>
+            <a:pPr marL="0" indent="0" algn="ctr">
+              <a:lnSpc>
+                <a:spcPct val="130000"/>
+              </a:lnSpc>
+              <a:buNone/>
+            </a:pPr>
+            <a:r>
+              <a:rPr lang="en-US" sz="950" dirty="0">
+                <a:solidFill>
+                  <a:srgbClr val="FFFFFF"/>
+                </a:solidFill>
+              </a:rPr>
+              <a:t>883 customers</a:t>
+            </a:r>
+            <a:endParaRPr lang="en-US" sz="950" dirty="0"/>
+          </a:p>
+          <a:p>
+            <a:pPr marL="0" indent="0" algn="ctr">
+              <a:lnSpc>
+                <a:spcPct val="130000"/>
+              </a:lnSpc>
+              <a:buNone/>
+            </a:pPr>
+            <a:r>
+              <a:rPr lang="en-US" sz="950" dirty="0">
+                <a:solidFill>
+                  <a:srgbClr val="FFFFFF"/>
+                </a:solidFill>
+              </a:rPr>
+              <a:t>£203K</a:t>
+            </a:r>
+            <a:endParaRPr lang="en-US" sz="950" dirty="0"/>
+          </a:p>
+        </p:txBody>
+      </p:sp>
+      <p:pic>
+        <p:nvPicPr>
+          <p:cNvPr id="22" name="Picture 21">
+            <a:extLst>
+              <a:ext uri="{FF2B5EF4-FFF2-40B4-BE49-F238E27FC236}">
+                <a16:creationId xmlns:a16="http://schemas.microsoft.com/office/drawing/2014/main" id="{2D17DFAA-E231-4796-A3F4-818C5183194D}"/>
+              </a:ext>
+            </a:extLst>
+          </p:cNvPr>
+          <p:cNvPicPr>
+            <a:picLocks noChangeAspect="1"/>
+          </p:cNvPicPr>
+          <p:nvPr/>
+        </p:nvPicPr>
+        <p:blipFill>
+          <a:blip r:embed="rId3"/>
+          <a:stretch>
+            <a:fillRect/>
+          </a:stretch>
+        </p:blipFill>
+        <p:spPr>
+          <a:xfrm>
+            <a:off x="0" y="0"/>
+            <a:ext cx="9144000" cy="4621618"/>
+          </a:xfrm>
+          <a:prstGeom prst="rect">
+            <a:avLst/>
+          </a:prstGeom>
+        </p:spPr>
+      </p:pic>
+    </p:spTree>
+    <p:extLst>
+      <p:ext uri="{BB962C8B-B14F-4D97-AF65-F5344CB8AC3E}">
+        <p14:creationId xmlns:p14="http://schemas.microsoft.com/office/powerpoint/2010/main" val="338581750"/>
+      </p:ext>
+    </p:extLst>
+  </p:cSld>
+  <p:clrMapOvr>
+    <a:masterClrMapping/>
+  </p:clrMapOvr>
+</p:sld>
+</file>
+
+<file path=ppt/slides/slide6.xml><?xml version="1.0" encoding="utf-8"?>
+<p:sld xmlns:a="http://schemas.openxmlformats.org/drawingml/2006/main" xmlns:r="http://schemas.openxmlformats.org/officeDocument/2006/relationships" xmlns:p="http://schemas.openxmlformats.org/presentationml/2006/main">
   <p:cSld name="Slide 5">
     <p:bg>
       <p:bgPr>
@@ -5236,7 +6110,7 @@
 </p:sld>
 </file>
 
-<file path=ppt/slides/slide6.xml><?xml version="1.0" encoding="utf-8"?>
+<file path=ppt/slides/slide7.xml><?xml version="1.0" encoding="utf-8"?>
 <p:sld xmlns:a="http://schemas.openxmlformats.org/drawingml/2006/main" xmlns:r="http://schemas.openxmlformats.org/officeDocument/2006/relationships" xmlns:p="http://schemas.openxmlformats.org/presentationml/2006/main">
   <p:cSld name="Slide 6">
     <p:bg>
@@ -5563,7 +6437,7 @@
 </p:sld>
 </file>
 
-<file path=ppt/slides/slide7.xml><?xml version="1.0" encoding="utf-8"?>
+<file path=ppt/slides/slide8.xml><?xml version="1.0" encoding="utf-8"?>
 <p:sld xmlns:a="http://schemas.openxmlformats.org/drawingml/2006/main" xmlns:r="http://schemas.openxmlformats.org/officeDocument/2006/relationships" xmlns:p="http://schemas.openxmlformats.org/presentationml/2006/main">
   <p:cSld name="Slide 7">
     <p:bg>
@@ -6296,7 +7170,7 @@
 </p:sld>
 </file>
 
-<file path=ppt/slides/slide8.xml><?xml version="1.0" encoding="utf-8"?>
+<file path=ppt/slides/slide9.xml><?xml version="1.0" encoding="utf-8"?>
 <p:sld xmlns:a="http://schemas.openxmlformats.org/drawingml/2006/main" xmlns:r="http://schemas.openxmlformats.org/officeDocument/2006/relationships" xmlns:p="http://schemas.openxmlformats.org/presentationml/2006/main">
   <p:cSld name="Slide 8">
     <p:bg>
@@ -6588,350 +7462,6 @@
               <a:t>• 💡 Focus onboarding on first 30 days post-purchase — this is the critical retention window</a:t>
             </a:r>
             <a:endParaRPr lang="en-US" sz="950" dirty="0"/>
-          </a:p>
-        </p:txBody>
-      </p:sp>
-    </p:spTree>
-  </p:cSld>
-  <p:clrMapOvr>
-    <a:masterClrMapping/>
-  </p:clrMapOvr>
-</p:sld>
-</file>
-
-<file path=ppt/slides/slide9.xml><?xml version="1.0" encoding="utf-8"?>
-<p:sld xmlns:a="http://schemas.openxmlformats.org/drawingml/2006/main" xmlns:r="http://schemas.openxmlformats.org/officeDocument/2006/relationships" xmlns:p="http://schemas.openxmlformats.org/presentationml/2006/main">
-  <p:cSld name="Slide 9">
-    <p:bg>
-      <p:bgPr>
-        <a:solidFill>
-          <a:srgbClr val="F8FAFC"/>
-        </a:solidFill>
-        <a:effectLst/>
-      </p:bgPr>
-    </p:bg>
-    <p:spTree>
-      <p:nvGrpSpPr>
-        <p:cNvPr id="1" name=""/>
-        <p:cNvGrpSpPr/>
-        <p:nvPr/>
-      </p:nvGrpSpPr>
-      <p:grpSpPr>
-        <a:xfrm>
-          <a:off x="0" y="0"/>
-          <a:ext cx="0" cy="0"/>
-          <a:chOff x="0" y="0"/>
-          <a:chExt cx="0" cy="0"/>
-        </a:xfrm>
-      </p:grpSpPr>
-      <p:sp>
-        <p:nvSpPr>
-          <p:cNvPr id="2" name="Shape 0"/>
-          <p:cNvSpPr/>
-          <p:nvPr/>
-        </p:nvSpPr>
-        <p:spPr>
-          <a:xfrm>
-            <a:off x="0" y="0"/>
-            <a:ext cx="9144000" cy="685800"/>
-          </a:xfrm>
-          <a:prstGeom prst="rect">
-            <a:avLst/>
-          </a:prstGeom>
-          <a:solidFill>
-            <a:srgbClr val="1B3A6B"/>
-          </a:solidFill>
-          <a:ln/>
-        </p:spPr>
-      </p:sp>
-      <p:sp>
-        <p:nvSpPr>
-          <p:cNvPr id="3" name="Text 1"/>
-          <p:cNvSpPr/>
-          <p:nvPr/>
-        </p:nvSpPr>
-        <p:spPr>
-          <a:xfrm>
-            <a:off x="365760" y="64008"/>
-            <a:ext cx="8412480" cy="548640"/>
-          </a:xfrm>
-          <a:prstGeom prst="rect">
-            <a:avLst/>
-          </a:prstGeom>
-          <a:noFill/>
-          <a:ln/>
-        </p:spPr>
-        <p:txBody>
-          <a:bodyPr wrap="square" rtlCol="0" anchor="ctr"/>
-          <a:lstStyle/>
-          <a:p>
-            <a:pPr marL="0" indent="0">
-              <a:buNone/>
-            </a:pPr>
-            <a:r>
-              <a:rPr lang="en-US" sz="2000" b="1" dirty="0">
-                <a:solidFill>
-                  <a:srgbClr val="FFFFFF"/>
-                </a:solidFill>
-              </a:rPr>
-              <a:t>Product Performance Insights</a:t>
-            </a:r>
-            <a:endParaRPr lang="en-US" sz="2000" dirty="0"/>
-          </a:p>
-        </p:txBody>
-      </p:sp>
-      <p:pic>
-        <p:nvPicPr>
-          <p:cNvPr id="4" name="Image 0" descr="preencoded.png"/>
-          <p:cNvPicPr>
-            <a:picLocks noChangeAspect="1"/>
-          </p:cNvPicPr>
-          <p:nvPr/>
-        </p:nvPicPr>
-        <p:blipFill>
-          <a:blip r:embed="rId3"/>
-          <a:stretch>
-            <a:fillRect/>
-          </a:stretch>
-        </p:blipFill>
-        <p:spPr>
-          <a:xfrm>
-            <a:off x="274320" y="777240"/>
-            <a:ext cx="4846320" cy="2331720"/>
-          </a:xfrm>
-          <a:prstGeom prst="rect">
-            <a:avLst/>
-          </a:prstGeom>
-        </p:spPr>
-      </p:pic>
-      <p:pic>
-        <p:nvPicPr>
-          <p:cNvPr id="5" name="Image 1" descr="preencoded.png"/>
-          <p:cNvPicPr>
-            <a:picLocks noChangeAspect="1"/>
-          </p:cNvPicPr>
-          <p:nvPr/>
-        </p:nvPicPr>
-        <p:blipFill>
-          <a:blip r:embed="rId4"/>
-          <a:stretch>
-            <a:fillRect/>
-          </a:stretch>
-        </p:blipFill>
-        <p:spPr>
-          <a:xfrm>
-            <a:off x="274320" y="3200400"/>
-            <a:ext cx="4846320" cy="1828800"/>
-          </a:xfrm>
-          <a:prstGeom prst="rect">
-            <a:avLst/>
-          </a:prstGeom>
-        </p:spPr>
-      </p:pic>
-      <p:sp>
-        <p:nvSpPr>
-          <p:cNvPr id="6" name="Shape 2"/>
-          <p:cNvSpPr/>
-          <p:nvPr/>
-        </p:nvSpPr>
-        <p:spPr>
-          <a:xfrm>
-            <a:off x="5303520" y="777240"/>
-            <a:ext cx="3566160" cy="4251960"/>
-          </a:xfrm>
-          <a:prstGeom prst="rect">
-            <a:avLst/>
-          </a:prstGeom>
-          <a:solidFill>
-            <a:srgbClr val="FFFFFF"/>
-          </a:solidFill>
-          <a:ln/>
-          <a:effectLst>
-            <a:outerShdw blurRad="101600" dist="38100" dir="16200000" algn="bl" rotWithShape="0">
-              <a:srgbClr val="000000">
-                <a:alpha val="10000"/>
-              </a:srgbClr>
-            </a:outerShdw>
-          </a:effectLst>
-        </p:spPr>
-      </p:sp>
-      <p:sp>
-        <p:nvSpPr>
-          <p:cNvPr id="7" name="Shape 3"/>
-          <p:cNvSpPr/>
-          <p:nvPr/>
-        </p:nvSpPr>
-        <p:spPr>
-          <a:xfrm>
-            <a:off x="5303520" y="777240"/>
-            <a:ext cx="64008" cy="4251960"/>
-          </a:xfrm>
-          <a:prstGeom prst="rect">
-            <a:avLst/>
-          </a:prstGeom>
-          <a:solidFill>
-            <a:srgbClr val="D97706"/>
-          </a:solidFill>
-          <a:ln/>
-        </p:spPr>
-      </p:sp>
-      <p:sp>
-        <p:nvSpPr>
-          <p:cNvPr id="8" name="Text 4"/>
-          <p:cNvSpPr/>
-          <p:nvPr/>
-        </p:nvSpPr>
-        <p:spPr>
-          <a:xfrm>
-            <a:off x="5486400" y="868680"/>
-            <a:ext cx="3200400" cy="365760"/>
-          </a:xfrm>
-          <a:prstGeom prst="rect">
-            <a:avLst/>
-          </a:prstGeom>
-          <a:noFill/>
-          <a:ln/>
-        </p:spPr>
-        <p:txBody>
-          <a:bodyPr wrap="square" rtlCol="0" anchor="ctr"/>
-          <a:lstStyle/>
-          <a:p>
-            <a:pPr marL="0" indent="0">
-              <a:buNone/>
-            </a:pPr>
-            <a:r>
-              <a:rPr lang="en-US" sz="1300" b="1" dirty="0">
-                <a:solidFill>
-                  <a:srgbClr val="1B3A6B"/>
-                </a:solidFill>
-              </a:rPr>
-              <a:t>Key Insights</a:t>
-            </a:r>
-            <a:endParaRPr lang="en-US" sz="1300" dirty="0"/>
-          </a:p>
-        </p:txBody>
-      </p:sp>
-      <p:sp>
-        <p:nvSpPr>
-          <p:cNvPr id="9" name="Text 5"/>
-          <p:cNvSpPr/>
-          <p:nvPr/>
-        </p:nvSpPr>
-        <p:spPr>
-          <a:xfrm>
-            <a:off x="5486400" y="1325880"/>
-            <a:ext cx="3200400" cy="3566160"/>
-          </a:xfrm>
-          <a:prstGeom prst="rect">
-            <a:avLst/>
-          </a:prstGeom>
-          <a:noFill/>
-          <a:ln/>
-        </p:spPr>
-        <p:txBody>
-          <a:bodyPr wrap="square" rtlCol="0" anchor="ctr"/>
-          <a:lstStyle/>
-          <a:p>
-            <a:pPr marL="0" indent="0">
-              <a:lnSpc>
-                <a:spcPct val="150000"/>
-              </a:lnSpc>
-              <a:buNone/>
-            </a:pPr>
-            <a:r>
-              <a:rPr lang="en-US" sz="1050" dirty="0">
-                <a:solidFill>
-                  <a:srgbClr val="0F172A"/>
-                </a:solidFill>
-              </a:rPr>
-              <a:t>🏆 Top 10 products generate disproportionate revenue</a:t>
-            </a:r>
-            <a:endParaRPr lang="en-US" sz="1050" dirty="0"/>
-          </a:p>
-          <a:p>
-            <a:pPr marL="0" indent="0">
-              <a:lnSpc>
-                <a:spcPct val="150000"/>
-              </a:lnSpc>
-              <a:buNone/>
-            </a:pPr>
-            <a:r>
-              <a:rPr lang="en-US" sz="1050" dirty="0">
-                <a:solidFill>
-                  <a:srgbClr val="0F172A"/>
-                </a:solidFill>
-              </a:rPr>
-              <a:t>🕯️ Decorative / gift items dominate top sellers</a:t>
-            </a:r>
-            <a:endParaRPr lang="en-US" sz="1050" dirty="0"/>
-          </a:p>
-          <a:p>
-            <a:pPr marL="0" indent="0">
-              <a:lnSpc>
-                <a:spcPct val="150000"/>
-              </a:lnSpc>
-              <a:buNone/>
-            </a:pPr>
-            <a:r>
-              <a:rPr lang="en-US" sz="1050" dirty="0">
-                <a:solidFill>
-                  <a:srgbClr val="0F172A"/>
-                </a:solidFill>
-              </a:rPr>
-              <a:t>⚠️  Many SKUs have &lt;£2 avg revenue per transaction</a:t>
-            </a:r>
-            <a:endParaRPr lang="en-US" sz="1050" dirty="0"/>
-          </a:p>
-          <a:p>
-            <a:pPr marL="0" indent="0">
-              <a:lnSpc>
-                <a:spcPct val="150000"/>
-              </a:lnSpc>
-              <a:buNone/>
-            </a:pPr>
-            <a:r>
-              <a:rPr lang="en-US" sz="1050" dirty="0">
-                <a:solidFill>
-                  <a:srgbClr val="0F172A"/>
-                </a:solidFill>
-              </a:rPr>
-              <a:t>📦 Bundling low-value items can boost basket size</a:t>
-            </a:r>
-            <a:endParaRPr lang="en-US" sz="1050" dirty="0"/>
-          </a:p>
-          <a:p>
-            <a:pPr marL="0" indent="0">
-              <a:lnSpc>
-                <a:spcPct val="150000"/>
-              </a:lnSpc>
-              <a:buNone/>
-            </a:pPr>
-            <a:r>
-              <a:rPr lang="en-US" sz="1050" dirty="0">
-                <a:solidFill>
-                  <a:srgbClr val="0F172A"/>
-                </a:solidFill>
-              </a:rPr>
-              <a:t>💡 Apply 80/20 rule: focus marketing budget on top 20% of SKUs</a:t>
-            </a:r>
-            <a:endParaRPr lang="en-US" sz="1050" dirty="0"/>
-          </a:p>
-          <a:p>
-            <a:pPr marL="0" indent="0">
-              <a:lnSpc>
-                <a:spcPct val="150000"/>
-              </a:lnSpc>
-              <a:buNone/>
-            </a:pPr>
-            <a:r>
-              <a:rPr lang="en-US" sz="1050" dirty="0">
-                <a:solidFill>
-                  <a:srgbClr val="0F172A"/>
-                </a:solidFill>
-              </a:rPr>
-              <a:t>🗑️ Consider discontinuing or repricing the bottom 50 SKUs</a:t>
-            </a:r>
-            <a:endParaRPr lang="en-US" sz="1050" dirty="0"/>
           </a:p>
         </p:txBody>
       </p:sp>

</xml_diff>